<commit_message>
aggiunti commenti ai file
</commit_message>
<xml_diff>
--- a/fileEsame/presentation.pptx
+++ b/fileEsame/presentation.pptx
@@ -278,7 +278,7 @@
           <a:p>
             <a:fld id="{74950A97-79D1-4BAA-8C1A-C26D640840E8}" type="datetimeFigureOut">
               <a:rPr lang="it-IT" smtClean="0"/>
-              <a:t>07/06/2025</a:t>
+              <a:t>26/06/2025</a:t>
             </a:fld>
             <a:endParaRPr lang="it-IT"/>
           </a:p>
@@ -476,7 +476,7 @@
           <a:p>
             <a:fld id="{74950A97-79D1-4BAA-8C1A-C26D640840E8}" type="datetimeFigureOut">
               <a:rPr lang="it-IT" smtClean="0"/>
-              <a:t>07/06/2025</a:t>
+              <a:t>26/06/2025</a:t>
             </a:fld>
             <a:endParaRPr lang="it-IT"/>
           </a:p>
@@ -684,7 +684,7 @@
           <a:p>
             <a:fld id="{74950A97-79D1-4BAA-8C1A-C26D640840E8}" type="datetimeFigureOut">
               <a:rPr lang="it-IT" smtClean="0"/>
-              <a:t>07/06/2025</a:t>
+              <a:t>26/06/2025</a:t>
             </a:fld>
             <a:endParaRPr lang="it-IT"/>
           </a:p>
@@ -882,7 +882,7 @@
           <a:p>
             <a:fld id="{74950A97-79D1-4BAA-8C1A-C26D640840E8}" type="datetimeFigureOut">
               <a:rPr lang="it-IT" smtClean="0"/>
-              <a:t>07/06/2025</a:t>
+              <a:t>26/06/2025</a:t>
             </a:fld>
             <a:endParaRPr lang="it-IT"/>
           </a:p>
@@ -1157,7 +1157,7 @@
           <a:p>
             <a:fld id="{74950A97-79D1-4BAA-8C1A-C26D640840E8}" type="datetimeFigureOut">
               <a:rPr lang="it-IT" smtClean="0"/>
-              <a:t>07/06/2025</a:t>
+              <a:t>26/06/2025</a:t>
             </a:fld>
             <a:endParaRPr lang="it-IT"/>
           </a:p>
@@ -1422,7 +1422,7 @@
           <a:p>
             <a:fld id="{74950A97-79D1-4BAA-8C1A-C26D640840E8}" type="datetimeFigureOut">
               <a:rPr lang="it-IT" smtClean="0"/>
-              <a:t>07/06/2025</a:t>
+              <a:t>26/06/2025</a:t>
             </a:fld>
             <a:endParaRPr lang="it-IT"/>
           </a:p>
@@ -1834,7 +1834,7 @@
           <a:p>
             <a:fld id="{74950A97-79D1-4BAA-8C1A-C26D640840E8}" type="datetimeFigureOut">
               <a:rPr lang="it-IT" smtClean="0"/>
-              <a:t>07/06/2025</a:t>
+              <a:t>26/06/2025</a:t>
             </a:fld>
             <a:endParaRPr lang="it-IT"/>
           </a:p>
@@ -1975,7 +1975,7 @@
           <a:p>
             <a:fld id="{74950A97-79D1-4BAA-8C1A-C26D640840E8}" type="datetimeFigureOut">
               <a:rPr lang="it-IT" smtClean="0"/>
-              <a:t>07/06/2025</a:t>
+              <a:t>26/06/2025</a:t>
             </a:fld>
             <a:endParaRPr lang="it-IT"/>
           </a:p>
@@ -2088,7 +2088,7 @@
           <a:p>
             <a:fld id="{74950A97-79D1-4BAA-8C1A-C26D640840E8}" type="datetimeFigureOut">
               <a:rPr lang="it-IT" smtClean="0"/>
-              <a:t>07/06/2025</a:t>
+              <a:t>26/06/2025</a:t>
             </a:fld>
             <a:endParaRPr lang="it-IT"/>
           </a:p>
@@ -2399,7 +2399,7 @@
           <a:p>
             <a:fld id="{74950A97-79D1-4BAA-8C1A-C26D640840E8}" type="datetimeFigureOut">
               <a:rPr lang="it-IT" smtClean="0"/>
-              <a:t>07/06/2025</a:t>
+              <a:t>26/06/2025</a:t>
             </a:fld>
             <a:endParaRPr lang="it-IT"/>
           </a:p>
@@ -2687,7 +2687,7 @@
           <a:p>
             <a:fld id="{74950A97-79D1-4BAA-8C1A-C26D640840E8}" type="datetimeFigureOut">
               <a:rPr lang="it-IT" smtClean="0"/>
-              <a:t>07/06/2025</a:t>
+              <a:t>26/06/2025</a:t>
             </a:fld>
             <a:endParaRPr lang="it-IT"/>
           </a:p>
@@ -2928,7 +2928,7 @@
           <a:p>
             <a:fld id="{74950A97-79D1-4BAA-8C1A-C26D640840E8}" type="datetimeFigureOut">
               <a:rPr lang="it-IT" smtClean="0"/>
-              <a:t>07/06/2025</a:t>
+              <a:t>26/06/2025</a:t>
             </a:fld>
             <a:endParaRPr lang="it-IT"/>
           </a:p>
@@ -5065,7 +5065,16 @@
             </a:pPr>
             <a:r>
               <a:rPr lang="it-IT" dirty="0"/>
-              <a:t>Il task di colorare video in bianco e nero è diventato negli ultimi anni molto importante poiché tutti i film e video in bianco e nero registrati all'inizio del 900 risultano poco accattivanti per una persona comune</a:t>
+              <a:t>A causa delle limitazioni tecniche dei vecchi dispositivi di imaging, molti video realizzati nel secolo scorso sono in bianco e nero, risultando meno coinvolgenti sugli schermi moderni. </a:t>
+            </a:r>
+          </a:p>
+          <a:p>
+            <a:pPr marL="0" indent="0">
+              <a:buNone/>
+            </a:pPr>
+            <a:r>
+              <a:rPr lang="it-IT" dirty="0"/>
+              <a:t>Poiché spesso hanno un grande valore storico e sono difficili da riprodurre, è fondamentale procedere alla loro colorizzazione.</a:t>
             </a:r>
           </a:p>
         </p:txBody>
@@ -5307,7 +5316,7 @@
           <a:p>
             <a:r>
               <a:rPr lang="it-IT" dirty="0"/>
-              <a:t>user-</a:t>
+              <a:t>User-</a:t>
             </a:r>
             <a:r>
               <a:rPr lang="it-IT" dirty="0" err="1"/>
@@ -5329,7 +5338,7 @@
           <a:p>
             <a:r>
               <a:rPr lang="it-IT" dirty="0" err="1"/>
-              <a:t>automatic</a:t>
+              <a:t>Automatic</a:t>
             </a:r>
             <a:r>
               <a:rPr lang="it-IT" dirty="0"/>
@@ -5348,14 +5357,14 @@
             <a:pPr lvl="1"/>
             <a:r>
               <a:rPr lang="it-IT" dirty="0"/>
-              <a:t>propagazione di features unidirezionale</a:t>
+              <a:t>Propagazione di features unidirezionale</a:t>
             </a:r>
           </a:p>
           <a:p>
             <a:pPr lvl="1"/>
             <a:r>
               <a:rPr lang="it-IT" dirty="0"/>
-              <a:t>propagazione bidirezionale</a:t>
+              <a:t>Propagazione bidirezionale</a:t>
             </a:r>
           </a:p>
           <a:p>
@@ -5371,7 +5380,7 @@
             </a:pPr>
             <a:r>
               <a:rPr lang="it-IT" dirty="0"/>
-              <a:t>	- risulta ancora poco soddisfacente stimare le features spaziali di ogni 	   frame</a:t>
+              <a:t>	- Risulta ancora poco soddisfacente stimare le features spaziali di ogni 	   frame</a:t>
             </a:r>
           </a:p>
           <a:p>
@@ -5380,7 +5389,7 @@
             </a:pPr>
             <a:r>
               <a:rPr lang="it-IT" dirty="0"/>
-              <a:t>	- performano male su scenari reali rispetto a dataset sintetici</a:t>
+              <a:t>	- Performano male su scenari reali rispetto a dataset sintetici</a:t>
             </a:r>
           </a:p>
         </p:txBody>
@@ -5467,7 +5476,7 @@
           <a:p>
             <a:r>
               <a:rPr lang="it-IT" dirty="0" err="1"/>
-              <a:t>exemplar-based</a:t>
+              <a:t>Exemplar-based</a:t>
             </a:r>
             <a:r>
               <a:rPr lang="it-IT" dirty="0"/>
@@ -5486,7 +5495,7 @@
             <a:pPr lvl="1"/>
             <a:r>
               <a:rPr lang="it-IT" dirty="0" err="1"/>
-              <a:t>stack</a:t>
+              <a:t>Stack</a:t>
             </a:r>
             <a:r>
               <a:rPr lang="it-IT" dirty="0"/>
@@ -5497,7 +5506,7 @@
             <a:pPr lvl="1"/>
             <a:r>
               <a:rPr lang="it-IT" dirty="0"/>
-              <a:t>propagazione di features basato su reti ricorrenti: fatica a sfruttare informazioni temporali molto distanti temporalmente fra di loro</a:t>
+              <a:t>Propagazione di features basato su reti ricorrenti: fatica a sfruttare informazioni temporali molto distanti temporalmente fra di loro</a:t>
             </a:r>
           </a:p>
         </p:txBody>

</xml_diff>